<commit_message>
fix: correct hero image aspect ratio on title slide
</commit_message>
<xml_diff>
--- a/lecture-1/modern-frontend-tooling.pptx
+++ b/lecture-1/modern-frontend-tooling.pptx
@@ -2948,8 +2948,8 @@
         </p:blipFill>
         <p:spPr>
           <a:xfrm>
-            <a:off x="6350000" y="0"/>
-            <a:ext cx="5842000" cy="6858000"/>
+            <a:off x="6350000" y="1778000"/>
+            <a:ext cx="5842000" cy="3289300"/>
           </a:xfrm>
           <a:prstGeom prst="rect">
             <a:avLst/>

</xml_diff>